<commit_message>
adding slide on python trainings
</commit_message>
<xml_diff>
--- a/slides-pptx/09-Python_intro-io.pptx
+++ b/slides-pptx/09-Python_intro-io.pptx
@@ -967,7 +967,7 @@
           <a:p>
             <a:fld id="{7A375BC9-5AAE-4E1F-9FAE-BC04149B1DB3}" type="datetimeFigureOut">
               <a:rPr lang="nl-BE" smtClean="0"/>
-              <a:t>12/02/2025</a:t>
+              <a:t>14/10/2025</a:t>
             </a:fld>
             <a:endParaRPr lang="nl-BE"/>
           </a:p>
@@ -1366,7 +1366,7 @@
           <a:p>
             <a:fld id="{25D4C14B-8B81-49E7-9BC7-8AE29B5E2ADB}" type="datetimeFigureOut">
               <a:rPr lang="nl-BE" smtClean="0"/>
-              <a:t>12/02/2025</a:t>
+              <a:t>14/10/2025</a:t>
             </a:fld>
             <a:endParaRPr lang="nl-BE"/>
           </a:p>
@@ -1536,7 +1536,7 @@
           <a:p>
             <a:fld id="{25D4C14B-8B81-49E7-9BC7-8AE29B5E2ADB}" type="datetimeFigureOut">
               <a:rPr lang="nl-BE" smtClean="0"/>
-              <a:t>12/02/2025</a:t>
+              <a:t>14/10/2025</a:t>
             </a:fld>
             <a:endParaRPr lang="nl-BE"/>
           </a:p>
@@ -1716,7 +1716,7 @@
           <a:p>
             <a:fld id="{25D4C14B-8B81-49E7-9BC7-8AE29B5E2ADB}" type="datetimeFigureOut">
               <a:rPr lang="nl-BE" smtClean="0"/>
-              <a:t>12/02/2025</a:t>
+              <a:t>14/10/2025</a:t>
             </a:fld>
             <a:endParaRPr lang="nl-BE"/>
           </a:p>
@@ -1886,7 +1886,7 @@
           <a:p>
             <a:fld id="{25D4C14B-8B81-49E7-9BC7-8AE29B5E2ADB}" type="datetimeFigureOut">
               <a:rPr lang="nl-BE" smtClean="0"/>
-              <a:t>12/02/2025</a:t>
+              <a:t>14/10/2025</a:t>
             </a:fld>
             <a:endParaRPr lang="nl-BE"/>
           </a:p>
@@ -2132,7 +2132,7 @@
           <a:p>
             <a:fld id="{25D4C14B-8B81-49E7-9BC7-8AE29B5E2ADB}" type="datetimeFigureOut">
               <a:rPr lang="nl-BE" smtClean="0"/>
-              <a:t>12/02/2025</a:t>
+              <a:t>14/10/2025</a:t>
             </a:fld>
             <a:endParaRPr lang="nl-BE"/>
           </a:p>
@@ -2364,7 +2364,7 @@
           <a:p>
             <a:fld id="{25D4C14B-8B81-49E7-9BC7-8AE29B5E2ADB}" type="datetimeFigureOut">
               <a:rPr lang="nl-BE" smtClean="0"/>
-              <a:t>12/02/2025</a:t>
+              <a:t>14/10/2025</a:t>
             </a:fld>
             <a:endParaRPr lang="nl-BE"/>
           </a:p>
@@ -2731,7 +2731,7 @@
           <a:p>
             <a:fld id="{25D4C14B-8B81-49E7-9BC7-8AE29B5E2ADB}" type="datetimeFigureOut">
               <a:rPr lang="nl-BE" smtClean="0"/>
-              <a:t>12/02/2025</a:t>
+              <a:t>14/10/2025</a:t>
             </a:fld>
             <a:endParaRPr lang="nl-BE"/>
           </a:p>
@@ -2849,7 +2849,7 @@
           <a:p>
             <a:fld id="{25D4C14B-8B81-49E7-9BC7-8AE29B5E2ADB}" type="datetimeFigureOut">
               <a:rPr lang="nl-BE" smtClean="0"/>
-              <a:t>12/02/2025</a:t>
+              <a:t>14/10/2025</a:t>
             </a:fld>
             <a:endParaRPr lang="nl-BE"/>
           </a:p>
@@ -2944,7 +2944,7 @@
           <a:p>
             <a:fld id="{25D4C14B-8B81-49E7-9BC7-8AE29B5E2ADB}" type="datetimeFigureOut">
               <a:rPr lang="nl-BE" smtClean="0"/>
-              <a:t>12/02/2025</a:t>
+              <a:t>14/10/2025</a:t>
             </a:fld>
             <a:endParaRPr lang="nl-BE"/>
           </a:p>
@@ -3221,7 +3221,7 @@
           <a:p>
             <a:fld id="{25D4C14B-8B81-49E7-9BC7-8AE29B5E2ADB}" type="datetimeFigureOut">
               <a:rPr lang="nl-BE" smtClean="0"/>
-              <a:t>12/02/2025</a:t>
+              <a:t>14/10/2025</a:t>
             </a:fld>
             <a:endParaRPr lang="nl-BE"/>
           </a:p>
@@ -3474,7 +3474,7 @@
           <a:p>
             <a:fld id="{25D4C14B-8B81-49E7-9BC7-8AE29B5E2ADB}" type="datetimeFigureOut">
               <a:rPr lang="nl-BE" smtClean="0"/>
-              <a:t>12/02/2025</a:t>
+              <a:t>14/10/2025</a:t>
             </a:fld>
             <a:endParaRPr lang="nl-BE"/>
           </a:p>
@@ -3687,7 +3687,7 @@
           <a:p>
             <a:fld id="{25D4C14B-8B81-49E7-9BC7-8AE29B5E2ADB}" type="datetimeFigureOut">
               <a:rPr lang="nl-BE" smtClean="0"/>
-              <a:t>12/02/2025</a:t>
+              <a:t>14/10/2025</a:t>
             </a:fld>
             <a:endParaRPr lang="nl-BE"/>
           </a:p>
@@ -4146,7 +4146,7 @@
           <a:p>
             <a:r>
               <a:rPr lang="en-US" dirty="0"/>
-              <a:t>IO</a:t>
+              <a:t>I/O</a:t>
             </a:r>
             <a:endParaRPr lang="nl-BE" dirty="0"/>
           </a:p>
@@ -4574,11 +4574,11 @@
                 <a:latin typeface="Courier New" panose="02070309020205020404" pitchFamily="49" charset="0"/>
                 <a:cs typeface="Courier New" panose="02070309020205020404" pitchFamily="49" charset="0"/>
               </a:rPr>
-              <a:t>'The {} in the {}'.format('car', ‘room')</a:t>
+              <a:t>'The {} in the {}'.format(‘elephant', ‘room')</a:t>
             </a:r>
             <a:r>
               <a:rPr lang="en-US" dirty="0"/>
-              <a:t> returns 'The car in the room'</a:t>
+              <a:t> returns 'The elephant in the room'</a:t>
             </a:r>
           </a:p>
           <a:p>
@@ -10408,11 +10408,11 @@
               <a:buNone/>
             </a:pPr>
             <a:r>
-              <a:rPr lang="en-US" dirty="0">
+              <a:rPr lang="en-US" sz="2400" dirty="0">
                 <a:latin typeface="Courier New" panose="02070309020205020404" pitchFamily="49" charset="0"/>
                 <a:cs typeface="Courier New" panose="02070309020205020404" pitchFamily="49" charset="0"/>
               </a:rPr>
-              <a:t>count = 5 </a:t>
+              <a:t>&gt;&gt;&gt; count = 5 </a:t>
             </a:r>
           </a:p>
           <a:p>
@@ -10420,11 +10420,11 @@
               <a:buNone/>
             </a:pPr>
             <a:r>
-              <a:rPr lang="en-US" dirty="0">
+              <a:rPr lang="en-US" sz="2400" dirty="0">
                 <a:latin typeface="Courier New" panose="02070309020205020404" pitchFamily="49" charset="0"/>
                 <a:cs typeface="Courier New" panose="02070309020205020404" pitchFamily="49" charset="0"/>
               </a:rPr>
-              <a:t>amount = 45.56 </a:t>
+              <a:t>&gt;&gt;&gt; amount = 45.56 </a:t>
             </a:r>
           </a:p>
           <a:p>
@@ -10432,13 +10432,25 @@
               <a:buNone/>
             </a:pPr>
             <a:r>
-              <a:rPr lang="en-US" dirty="0">
+              <a:rPr lang="en-US" sz="2400" dirty="0">
                 <a:latin typeface="Courier New" panose="02070309020205020404" pitchFamily="49" charset="0"/>
                 <a:cs typeface="Courier New" panose="02070309020205020404" pitchFamily="49" charset="0"/>
               </a:rPr>
-              <a:t>print(‘count is {0} and amount is {1:9.6f}’.format(count, amount))</a:t>
-            </a:r>
-            <a:endParaRPr lang="nl-BE" dirty="0">
+              <a:t>&gt;&gt;&gt; print(‘count is {0} and amount is {1:9.6f}’.format(count, amount))</a:t>
+            </a:r>
+          </a:p>
+          <a:p>
+            <a:pPr marL="0" indent="0">
+              <a:buNone/>
+            </a:pPr>
+            <a:r>
+              <a:rPr lang="en-US" sz="2400" dirty="0">
+                <a:latin typeface="Courier New" panose="02070309020205020404" pitchFamily="49" charset="0"/>
+                <a:cs typeface="Courier New" panose="02070309020205020404" pitchFamily="49" charset="0"/>
+              </a:rPr>
+              <a:t>count is 5 and amount is 45.560000</a:t>
+            </a:r>
+            <a:endParaRPr lang="nl-BE" sz="2400" dirty="0">
               <a:latin typeface="Courier New" panose="02070309020205020404" pitchFamily="49" charset="0"/>
               <a:cs typeface="Courier New" panose="02070309020205020404" pitchFamily="49" charset="0"/>
             </a:endParaRPr>
@@ -15139,7 +15151,7 @@
                 <a:latin typeface="Courier New" panose="02070309020205020404" pitchFamily="49" charset="0"/>
                 <a:cs typeface="Courier New" panose="02070309020205020404" pitchFamily="49" charset="0"/>
               </a:rPr>
-              <a:t>))</a:t>
+              <a:t>[1:]))</a:t>
             </a:r>
           </a:p>
           <a:p>
@@ -15167,15 +15179,6 @@
               </a:rPr>
               <a:t>)</a:t>
             </a:r>
-          </a:p>
-          <a:p>
-            <a:pPr marL="0" indent="0">
-              <a:buNone/>
-            </a:pPr>
-            <a:endParaRPr lang="en-US" dirty="0">
-              <a:latin typeface="Courier New" panose="02070309020205020404" pitchFamily="49" charset="0"/>
-              <a:cs typeface="Courier New" panose="02070309020205020404" pitchFamily="49" charset="0"/>
-            </a:endParaRPr>
           </a:p>
           <a:p>
             <a:pPr marL="0" indent="0">
@@ -15352,7 +15355,7 @@
                 <a:latin typeface="Courier New" panose="02070309020205020404" pitchFamily="49" charset="0"/>
                 <a:cs typeface="Courier New" panose="02070309020205020404" pitchFamily="49" charset="0"/>
               </a:rPr>
-              <a:t>python .\command_line_io.py help me</a:t>
+              <a:t>python .\command_line_io.py help 12</a:t>
             </a:r>
           </a:p>
           <a:p>
@@ -15376,7 +15379,7 @@
                 <a:latin typeface="Courier New" panose="02070309020205020404" pitchFamily="49" charset="0"/>
                 <a:cs typeface="Courier New" panose="02070309020205020404" pitchFamily="49" charset="0"/>
               </a:rPr>
-              <a:t>Number of arguments:  3</a:t>
+              <a:t>Number of arguments:  2</a:t>
             </a:r>
           </a:p>
           <a:p>
@@ -15388,7 +15391,7 @@
                 <a:latin typeface="Courier New" panose="02070309020205020404" pitchFamily="49" charset="0"/>
                 <a:cs typeface="Courier New" panose="02070309020205020404" pitchFamily="49" charset="0"/>
               </a:rPr>
-              <a:t>The arguments are:  ['.\\command_line_io.py', 'help', 'me']</a:t>
+              <a:t>The arguments are:  ['.\\command_line_io.py', 'help', ‘12']</a:t>
             </a:r>
           </a:p>
           <a:p>
@@ -15424,7 +15427,7 @@
                 <a:latin typeface="Courier New" panose="02070309020205020404" pitchFamily="49" charset="0"/>
                 <a:cs typeface="Courier New" panose="02070309020205020404" pitchFamily="49" charset="0"/>
               </a:rPr>
-              <a:t>&lt;class 'str'&gt; me</a:t>
+              <a:t>&lt;class 'str’&gt; 12</a:t>
             </a:r>
           </a:p>
           <a:p>
@@ -33181,6 +33184,13 @@
               <a:buNone/>
             </a:pPr>
             <a:r>
+              <a:rPr lang="en-US" dirty="0">
+                <a:latin typeface="Courier New" panose="02070309020205020404" pitchFamily="49" charset="0"/>
+                <a:cs typeface="Courier New" panose="02070309020205020404" pitchFamily="49" charset="0"/>
+              </a:rPr>
+              <a:t>&gt;&gt;&gt; </a:t>
+            </a:r>
+            <a:r>
               <a:rPr lang="en-US" dirty="0" err="1">
                 <a:latin typeface="Courier New" panose="02070309020205020404" pitchFamily="49" charset="0"/>
                 <a:cs typeface="Courier New" panose="02070309020205020404" pitchFamily="49" charset="0"/>
@@ -33192,7 +33202,7 @@
                 <a:latin typeface="Courier New" panose="02070309020205020404" pitchFamily="49" charset="0"/>
                 <a:cs typeface="Courier New" panose="02070309020205020404" pitchFamily="49" charset="0"/>
               </a:rPr>
-              <a:t> =open ("</a:t>
+              <a:t> =open("</a:t>
             </a:r>
             <a:r>
               <a:rPr lang="en-US" dirty="0" err="1">
@@ -33214,6 +33224,13 @@
               <a:buNone/>
             </a:pPr>
             <a:r>
+              <a:rPr lang="en-US" dirty="0">
+                <a:latin typeface="Courier New" panose="02070309020205020404" pitchFamily="49" charset="0"/>
+                <a:cs typeface="Courier New" panose="02070309020205020404" pitchFamily="49" charset="0"/>
+              </a:rPr>
+              <a:t>&gt;&gt;&gt; </a:t>
+            </a:r>
+            <a:r>
               <a:rPr lang="en-US" dirty="0" err="1">
                 <a:latin typeface="Courier New" panose="02070309020205020404" pitchFamily="49" charset="0"/>
                 <a:cs typeface="Courier New" panose="02070309020205020404" pitchFamily="49" charset="0"/>
@@ -33234,7 +33251,7 @@
             </a:pPr>
             <a:r>
               <a:rPr lang="en-US" dirty="0"/>
-              <a:t>Specify number of bytes</a:t>
+              <a:t>Specify the number of bytes</a:t>
             </a:r>
           </a:p>
           <a:p>
@@ -33242,6 +33259,13 @@
               <a:buNone/>
             </a:pPr>
             <a:r>
+              <a:rPr lang="en-US" dirty="0">
+                <a:latin typeface="Courier New" panose="02070309020205020404" pitchFamily="49" charset="0"/>
+                <a:cs typeface="Courier New" panose="02070309020205020404" pitchFamily="49" charset="0"/>
+              </a:rPr>
+              <a:t>&gt;&gt;&gt; </a:t>
+            </a:r>
+            <a:r>
               <a:rPr lang="en-US" dirty="0" err="1">
                 <a:latin typeface="Courier New" panose="02070309020205020404" pitchFamily="49" charset="0"/>
                 <a:cs typeface="Courier New" panose="02070309020205020404" pitchFamily="49" charset="0"/>
@@ -33253,7 +33277,7 @@
                 <a:latin typeface="Courier New" panose="02070309020205020404" pitchFamily="49" charset="0"/>
                 <a:cs typeface="Courier New" panose="02070309020205020404" pitchFamily="49" charset="0"/>
               </a:rPr>
-              <a:t> =open ("</a:t>
+              <a:t> = open("</a:t>
             </a:r>
             <a:r>
               <a:rPr lang="en-US" dirty="0" err="1">
@@ -33274,6 +33298,13 @@
             <a:pPr marL="0" indent="0">
               <a:buNone/>
             </a:pPr>
+            <a:r>
+              <a:rPr lang="en-US" dirty="0">
+                <a:latin typeface="Courier New" panose="02070309020205020404" pitchFamily="49" charset="0"/>
+                <a:cs typeface="Courier New" panose="02070309020205020404" pitchFamily="49" charset="0"/>
+              </a:rPr>
+              <a:t>&gt;&gt;&gt; </a:t>
+            </a:r>
             <a:r>
               <a:rPr lang="en-US" dirty="0" err="1">
                 <a:latin typeface="Courier New" panose="02070309020205020404" pitchFamily="49" charset="0"/>
@@ -33444,21 +33475,21 @@
               <a:t> </a:t>
             </a:r>
             <a:r>
-              <a:rPr lang="en-US" dirty="0">
+              <a:rPr lang="en-US" sz="2400" dirty="0">
                 <a:latin typeface="Courier New" panose="02070309020205020404" pitchFamily="49" charset="0"/>
                 <a:cs typeface="Courier New" panose="02070309020205020404" pitchFamily="49" charset="0"/>
               </a:rPr>
-              <a:t>with open('</a:t>
-            </a:r>
-            <a:r>
-              <a:rPr lang="en-US" dirty="0" err="1">
+              <a:t>&gt;&gt;&gt; with open('</a:t>
+            </a:r>
+            <a:r>
+              <a:rPr lang="en-US" sz="2400" dirty="0" err="1">
                 <a:latin typeface="Courier New" panose="02070309020205020404" pitchFamily="49" charset="0"/>
                 <a:cs typeface="Courier New" panose="02070309020205020404" pitchFamily="49" charset="0"/>
               </a:rPr>
               <a:t>file_path</a:t>
             </a:r>
             <a:r>
-              <a:rPr lang="en-US" dirty="0">
+              <a:rPr lang="en-US" sz="2400" dirty="0">
                 <a:latin typeface="Courier New" panose="02070309020205020404" pitchFamily="49" charset="0"/>
                 <a:cs typeface="Courier New" panose="02070309020205020404" pitchFamily="49" charset="0"/>
               </a:rPr>
@@ -33470,21 +33501,21 @@
               <a:buNone/>
             </a:pPr>
             <a:r>
-              <a:rPr lang="en-US" dirty="0">
+              <a:rPr lang="en-US" sz="2400" dirty="0">
                 <a:latin typeface="Courier New" panose="02070309020205020404" pitchFamily="49" charset="0"/>
                 <a:cs typeface="Courier New" panose="02070309020205020404" pitchFamily="49" charset="0"/>
               </a:rPr>
-              <a:t>    </a:t>
-            </a:r>
-            <a:r>
-              <a:rPr lang="en-US" dirty="0" err="1">
+              <a:t>         </a:t>
+            </a:r>
+            <a:r>
+              <a:rPr lang="en-US" sz="2400" dirty="0" err="1">
                 <a:latin typeface="Courier New" panose="02070309020205020404" pitchFamily="49" charset="0"/>
                 <a:cs typeface="Courier New" panose="02070309020205020404" pitchFamily="49" charset="0"/>
               </a:rPr>
               <a:t>file.write</a:t>
             </a:r>
             <a:r>
-              <a:rPr lang="en-US" dirty="0">
+              <a:rPr lang="en-US" sz="2400" dirty="0">
                 <a:latin typeface="Courier New" panose="02070309020205020404" pitchFamily="49" charset="0"/>
                 <a:cs typeface="Courier New" panose="02070309020205020404" pitchFamily="49" charset="0"/>
               </a:rPr>
@@ -35050,13 +35081,13 @@
         <p:spPr/>
         <p:txBody>
           <a:bodyPr>
-            <a:normAutofit fontScale="92500" lnSpcReduction="10000"/>
+            <a:normAutofit lnSpcReduction="10000"/>
           </a:bodyPr>
           <a:lstStyle/>
           <a:p>
             <a:r>
               <a:rPr lang="en-US" dirty="0"/>
-              <a:t>Problem: Not portable code,   data type size?   Encoding?   little /big endian?</a:t>
+              <a:t>Problem: Not portable code, data type size? Encoding? little /big endian?</a:t>
             </a:r>
           </a:p>
           <a:p>
@@ -35104,7 +35135,7 @@
                 <a:latin typeface="Courier New" panose="02070309020205020404" pitchFamily="49" charset="0"/>
                 <a:cs typeface="Courier New" panose="02070309020205020404" pitchFamily="49" charset="0"/>
               </a:rPr>
-              <a:t>json</a:t>
+              <a:t>json,yaml</a:t>
             </a:r>
             <a:r>
               <a:rPr lang="en-US" dirty="0"/>
@@ -35592,7 +35623,7 @@
           <a:p>
             <a:r>
               <a:rPr lang="en-US" dirty="0"/>
-              <a:t>The writer class has following methods</a:t>
+              <a:t>The writer class has the following methods</a:t>
             </a:r>
           </a:p>
           <a:p>
@@ -35750,7 +35781,7 @@
           <a:p>
             <a:r>
               <a:rPr lang="en-US" dirty="0"/>
-              <a:t>IO</a:t>
+              <a:t>I/O</a:t>
             </a:r>
             <a:endParaRPr lang="nl-BE" dirty="0"/>
           </a:p>
@@ -37316,7 +37347,7 @@
               <a:rPr lang="en-US" dirty="0">
                 <a:cs typeface="Courier New" panose="02070309020205020404" pitchFamily="49" charset="0"/>
               </a:rPr>
-              <a:t> - objects to the printed. </a:t>
+              <a:t> - objects to be printed. </a:t>
             </a:r>
           </a:p>
           <a:p>

</xml_diff>